<commit_message>
updated architecture diagram ppt
</commit_message>
<xml_diff>
--- a/design mockups/Updated architecture diagram.pptx
+++ b/design mockups/Updated architecture diagram.pptx
@@ -6,6 +6,7 @@
   </p:sldMasterIdLst>
   <p:sldIdLst>
     <p:sldId id="256" r:id="rId2"/>
+    <p:sldId id="257" r:id="rId3"/>
   </p:sldIdLst>
   <p:sldSz cx="12192000" cy="6858000"/>
   <p:notesSz cx="6858000" cy="9144000"/>
@@ -104,6 +105,11 @@
       </a:defRPr>
     </a:lvl9pPr>
   </p:defaultTextStyle>
+  <p:extLst>
+    <p:ext uri="{EFAFB233-063F-42B5-8137-9DF3F51BA10A}">
+      <p15:sldGuideLst xmlns:p15="http://schemas.microsoft.com/office/powerpoint/2012/main"/>
+    </p:ext>
+  </p:extLst>
 </p:presentation>
 </file>
 
@@ -254,7 +260,7 @@
           <a:p>
             <a:fld id="{2CF3A2DC-A5E9-427C-B507-7A97A025D991}" type="datetimeFigureOut">
               <a:rPr lang="en-US" smtClean="0"/>
-              <a:t>3/31/2026</a:t>
+              <a:t>4/24/2026</a:t>
             </a:fld>
             <a:endParaRPr lang="en-US"/>
           </a:p>
@@ -452,7 +458,7 @@
           <a:p>
             <a:fld id="{2CF3A2DC-A5E9-427C-B507-7A97A025D991}" type="datetimeFigureOut">
               <a:rPr lang="en-US" smtClean="0"/>
-              <a:t>3/31/2026</a:t>
+              <a:t>4/24/2026</a:t>
             </a:fld>
             <a:endParaRPr lang="en-US"/>
           </a:p>
@@ -660,7 +666,7 @@
           <a:p>
             <a:fld id="{2CF3A2DC-A5E9-427C-B507-7A97A025D991}" type="datetimeFigureOut">
               <a:rPr lang="en-US" smtClean="0"/>
-              <a:t>3/31/2026</a:t>
+              <a:t>4/24/2026</a:t>
             </a:fld>
             <a:endParaRPr lang="en-US"/>
           </a:p>
@@ -858,7 +864,7 @@
           <a:p>
             <a:fld id="{2CF3A2DC-A5E9-427C-B507-7A97A025D991}" type="datetimeFigureOut">
               <a:rPr lang="en-US" smtClean="0"/>
-              <a:t>3/31/2026</a:t>
+              <a:t>4/24/2026</a:t>
             </a:fld>
             <a:endParaRPr lang="en-US"/>
           </a:p>
@@ -1133,7 +1139,7 @@
           <a:p>
             <a:fld id="{2CF3A2DC-A5E9-427C-B507-7A97A025D991}" type="datetimeFigureOut">
               <a:rPr lang="en-US" smtClean="0"/>
-              <a:t>3/31/2026</a:t>
+              <a:t>4/24/2026</a:t>
             </a:fld>
             <a:endParaRPr lang="en-US"/>
           </a:p>
@@ -1398,7 +1404,7 @@
           <a:p>
             <a:fld id="{2CF3A2DC-A5E9-427C-B507-7A97A025D991}" type="datetimeFigureOut">
               <a:rPr lang="en-US" smtClean="0"/>
-              <a:t>3/31/2026</a:t>
+              <a:t>4/24/2026</a:t>
             </a:fld>
             <a:endParaRPr lang="en-US"/>
           </a:p>
@@ -1810,7 +1816,7 @@
           <a:p>
             <a:fld id="{2CF3A2DC-A5E9-427C-B507-7A97A025D991}" type="datetimeFigureOut">
               <a:rPr lang="en-US" smtClean="0"/>
-              <a:t>3/31/2026</a:t>
+              <a:t>4/24/2026</a:t>
             </a:fld>
             <a:endParaRPr lang="en-US"/>
           </a:p>
@@ -1951,7 +1957,7 @@
           <a:p>
             <a:fld id="{2CF3A2DC-A5E9-427C-B507-7A97A025D991}" type="datetimeFigureOut">
               <a:rPr lang="en-US" smtClean="0"/>
-              <a:t>3/31/2026</a:t>
+              <a:t>4/24/2026</a:t>
             </a:fld>
             <a:endParaRPr lang="en-US"/>
           </a:p>
@@ -2064,7 +2070,7 @@
           <a:p>
             <a:fld id="{2CF3A2DC-A5E9-427C-B507-7A97A025D991}" type="datetimeFigureOut">
               <a:rPr lang="en-US" smtClean="0"/>
-              <a:t>3/31/2026</a:t>
+              <a:t>4/24/2026</a:t>
             </a:fld>
             <a:endParaRPr lang="en-US"/>
           </a:p>
@@ -2375,7 +2381,7 @@
           <a:p>
             <a:fld id="{2CF3A2DC-A5E9-427C-B507-7A97A025D991}" type="datetimeFigureOut">
               <a:rPr lang="en-US" smtClean="0"/>
-              <a:t>3/31/2026</a:t>
+              <a:t>4/24/2026</a:t>
             </a:fld>
             <a:endParaRPr lang="en-US"/>
           </a:p>
@@ -2663,7 +2669,7 @@
           <a:p>
             <a:fld id="{2CF3A2DC-A5E9-427C-B507-7A97A025D991}" type="datetimeFigureOut">
               <a:rPr lang="en-US" smtClean="0"/>
-              <a:t>3/31/2026</a:t>
+              <a:t>4/24/2026</a:t>
             </a:fld>
             <a:endParaRPr lang="en-US"/>
           </a:p>
@@ -2904,7 +2910,7 @@
           <a:p>
             <a:fld id="{2CF3A2DC-A5E9-427C-B507-7A97A025D991}" type="datetimeFigureOut">
               <a:rPr lang="en-US" smtClean="0"/>
-              <a:t>3/31/2026</a:t>
+              <a:t>4/24/2026</a:t>
             </a:fld>
             <a:endParaRPr lang="en-US"/>
           </a:p>
@@ -4772,6 +4778,2508 @@
 </p:sld>
 </file>
 
+<file path=ppt/slides/slide2.xml><?xml version="1.0" encoding="utf-8"?>
+<p:sld xmlns:a="http://schemas.openxmlformats.org/drawingml/2006/main" xmlns:r="http://schemas.openxmlformats.org/officeDocument/2006/relationships" xmlns:p="http://schemas.openxmlformats.org/presentationml/2006/main">
+  <p:cSld>
+    <p:spTree>
+      <p:nvGrpSpPr>
+        <p:cNvPr id="1" name="">
+          <a:extLst>
+            <a:ext uri="{FF2B5EF4-FFF2-40B4-BE49-F238E27FC236}">
+              <a16:creationId xmlns:a16="http://schemas.microsoft.com/office/drawing/2014/main" id="{1ED10581-AF94-11E4-95C0-D453BE8AE39D}"/>
+            </a:ext>
+          </a:extLst>
+        </p:cNvPr>
+        <p:cNvGrpSpPr/>
+        <p:nvPr/>
+      </p:nvGrpSpPr>
+      <p:grpSpPr>
+        <a:xfrm>
+          <a:off x="0" y="0"/>
+          <a:ext cx="0" cy="0"/>
+          <a:chOff x="0" y="0"/>
+          <a:chExt cx="0" cy="0"/>
+        </a:xfrm>
+      </p:grpSpPr>
+      <p:grpSp>
+        <p:nvGrpSpPr>
+          <p:cNvPr id="38" name="Group 37">
+            <a:extLst>
+              <a:ext uri="{FF2B5EF4-FFF2-40B4-BE49-F238E27FC236}">
+                <a16:creationId xmlns:a16="http://schemas.microsoft.com/office/drawing/2014/main" id="{2D39D2C7-3FD5-3FD6-CC53-E78F8D531454}"/>
+              </a:ext>
+            </a:extLst>
+          </p:cNvPr>
+          <p:cNvGrpSpPr/>
+          <p:nvPr/>
+        </p:nvGrpSpPr>
+        <p:grpSpPr>
+          <a:xfrm>
+            <a:off x="196293" y="15156"/>
+            <a:ext cx="12113337" cy="6773670"/>
+            <a:chOff x="196293" y="15156"/>
+            <a:chExt cx="12113337" cy="6773670"/>
+          </a:xfrm>
+        </p:grpSpPr>
+        <p:sp>
+          <p:nvSpPr>
+            <p:cNvPr id="7" name="Rectangle: Rounded Corners 6">
+              <a:extLst>
+                <a:ext uri="{FF2B5EF4-FFF2-40B4-BE49-F238E27FC236}">
+                  <a16:creationId xmlns:a16="http://schemas.microsoft.com/office/drawing/2014/main" id="{3D07D2B9-5EBC-7E94-FA6E-88259D4838C4}"/>
+                </a:ext>
+              </a:extLst>
+            </p:cNvPr>
+            <p:cNvSpPr/>
+            <p:nvPr/>
+          </p:nvSpPr>
+          <p:spPr>
+            <a:xfrm>
+              <a:off x="8007427" y="2872955"/>
+              <a:ext cx="3133891" cy="1961569"/>
+            </a:xfrm>
+            <a:prstGeom prst="roundRect">
+              <a:avLst/>
+            </a:prstGeom>
+            <a:solidFill>
+              <a:schemeClr val="tx2">
+                <a:lumMod val="10000"/>
+                <a:lumOff val="90000"/>
+              </a:schemeClr>
+            </a:solidFill>
+            <a:ln>
+              <a:solidFill>
+                <a:schemeClr val="tx2">
+                  <a:lumMod val="25000"/>
+                  <a:lumOff val="75000"/>
+                </a:schemeClr>
+              </a:solidFill>
+            </a:ln>
+          </p:spPr>
+          <p:style>
+            <a:lnRef idx="2">
+              <a:schemeClr val="accent1">
+                <a:shade val="15000"/>
+              </a:schemeClr>
+            </a:lnRef>
+            <a:fillRef idx="1">
+              <a:schemeClr val="accent1"/>
+            </a:fillRef>
+            <a:effectRef idx="0">
+              <a:schemeClr val="accent1"/>
+            </a:effectRef>
+            <a:fontRef idx="minor">
+              <a:schemeClr val="lt1"/>
+            </a:fontRef>
+          </p:style>
+          <p:txBody>
+            <a:bodyPr rtlCol="0" anchor="ctr"/>
+            <a:lstStyle/>
+            <a:p>
+              <a:pPr algn="ctr"/>
+              <a:r>
+                <a:rPr lang="en-US" sz="2000" b="1" dirty="0">
+                  <a:solidFill>
+                    <a:schemeClr val="tx2">
+                      <a:lumMod val="50000"/>
+                      <a:lumOff val="50000"/>
+                    </a:schemeClr>
+                  </a:solidFill>
+                </a:rPr>
+                <a:t>Index.html/style.css</a:t>
+              </a:r>
+            </a:p>
+            <a:p>
+              <a:pPr algn="ctr"/>
+              <a:r>
+                <a:rPr lang="en-US" i="1" dirty="0">
+                  <a:solidFill>
+                    <a:schemeClr val="tx2">
+                      <a:lumMod val="50000"/>
+                      <a:lumOff val="50000"/>
+                    </a:schemeClr>
+                  </a:solidFill>
+                </a:rPr>
+                <a:t>Interactive map </a:t>
+              </a:r>
+              <a:r>
+                <a:rPr lang="en-US" b="1" dirty="0">
+                  <a:solidFill>
+                    <a:schemeClr val="tx2">
+                      <a:lumMod val="50000"/>
+                      <a:lumOff val="50000"/>
+                    </a:schemeClr>
+                  </a:solidFill>
+                </a:rPr>
+                <a:t>INTERFACE</a:t>
+              </a:r>
+            </a:p>
+          </p:txBody>
+        </p:sp>
+        <p:sp>
+          <p:nvSpPr>
+            <p:cNvPr id="8" name="Rectangle: Rounded Corners 7">
+              <a:extLst>
+                <a:ext uri="{FF2B5EF4-FFF2-40B4-BE49-F238E27FC236}">
+                  <a16:creationId xmlns:a16="http://schemas.microsoft.com/office/drawing/2014/main" id="{1E996227-E328-00CD-BEB4-F04EE280F764}"/>
+                </a:ext>
+              </a:extLst>
+            </p:cNvPr>
+            <p:cNvSpPr/>
+            <p:nvPr/>
+          </p:nvSpPr>
+          <p:spPr>
+            <a:xfrm>
+              <a:off x="4372199" y="2872957"/>
+              <a:ext cx="3133891" cy="1961569"/>
+            </a:xfrm>
+            <a:prstGeom prst="roundRect">
+              <a:avLst/>
+            </a:prstGeom>
+            <a:solidFill>
+              <a:schemeClr val="tx2">
+                <a:lumMod val="10000"/>
+                <a:lumOff val="90000"/>
+              </a:schemeClr>
+            </a:solidFill>
+            <a:ln>
+              <a:solidFill>
+                <a:schemeClr val="tx2">
+                  <a:lumMod val="25000"/>
+                  <a:lumOff val="75000"/>
+                </a:schemeClr>
+              </a:solidFill>
+            </a:ln>
+          </p:spPr>
+          <p:style>
+            <a:lnRef idx="2">
+              <a:schemeClr val="accent1">
+                <a:shade val="15000"/>
+              </a:schemeClr>
+            </a:lnRef>
+            <a:fillRef idx="1">
+              <a:schemeClr val="accent1"/>
+            </a:fillRef>
+            <a:effectRef idx="0">
+              <a:schemeClr val="accent1"/>
+            </a:effectRef>
+            <a:fontRef idx="minor">
+              <a:schemeClr val="lt1"/>
+            </a:fontRef>
+          </p:style>
+          <p:txBody>
+            <a:bodyPr rtlCol="0" anchor="ctr"/>
+            <a:lstStyle/>
+            <a:p>
+              <a:pPr algn="ctr"/>
+              <a:r>
+                <a:rPr lang="en-US" sz="2000" b="1" dirty="0">
+                  <a:solidFill>
+                    <a:schemeClr val="tx2">
+                      <a:lumMod val="50000"/>
+                      <a:lumOff val="50000"/>
+                    </a:schemeClr>
+                  </a:solidFill>
+                </a:rPr>
+                <a:t>App.py</a:t>
+              </a:r>
+            </a:p>
+            <a:p>
+              <a:pPr algn="ctr"/>
+              <a:r>
+                <a:rPr lang="en-US" b="1" dirty="0">
+                  <a:solidFill>
+                    <a:schemeClr val="tx2">
+                      <a:lumMod val="50000"/>
+                      <a:lumOff val="50000"/>
+                    </a:schemeClr>
+                  </a:solidFill>
+                </a:rPr>
+                <a:t>API LAYER</a:t>
+              </a:r>
+              <a:r>
+                <a:rPr lang="en-US" b="1" i="1" dirty="0">
+                  <a:solidFill>
+                    <a:schemeClr val="tx2">
+                      <a:lumMod val="50000"/>
+                      <a:lumOff val="50000"/>
+                    </a:schemeClr>
+                  </a:solidFill>
+                </a:rPr>
+                <a:t> </a:t>
+              </a:r>
+              <a:r>
+                <a:rPr lang="en-US" i="1" dirty="0">
+                  <a:solidFill>
+                    <a:schemeClr val="tx2">
+                      <a:lumMod val="50000"/>
+                      <a:lumOff val="50000"/>
+                    </a:schemeClr>
+                  </a:solidFill>
+                </a:rPr>
+                <a:t>connecting backend &amp; user interface</a:t>
+              </a:r>
+            </a:p>
+          </p:txBody>
+        </p:sp>
+        <p:sp>
+          <p:nvSpPr>
+            <p:cNvPr id="9" name="Rectangle: Rounded Corners 8">
+              <a:extLst>
+                <a:ext uri="{FF2B5EF4-FFF2-40B4-BE49-F238E27FC236}">
+                  <a16:creationId xmlns:a16="http://schemas.microsoft.com/office/drawing/2014/main" id="{4C7675CE-E296-68B2-6565-72BC89411145}"/>
+                </a:ext>
+              </a:extLst>
+            </p:cNvPr>
+            <p:cNvSpPr/>
+            <p:nvPr/>
+          </p:nvSpPr>
+          <p:spPr>
+            <a:xfrm>
+              <a:off x="736971" y="2872955"/>
+              <a:ext cx="3133891" cy="1961569"/>
+            </a:xfrm>
+            <a:prstGeom prst="roundRect">
+              <a:avLst/>
+            </a:prstGeom>
+            <a:solidFill>
+              <a:schemeClr val="tx2">
+                <a:lumMod val="10000"/>
+                <a:lumOff val="90000"/>
+              </a:schemeClr>
+            </a:solidFill>
+            <a:ln>
+              <a:solidFill>
+                <a:schemeClr val="tx2">
+                  <a:lumMod val="25000"/>
+                  <a:lumOff val="75000"/>
+                </a:schemeClr>
+              </a:solidFill>
+            </a:ln>
+          </p:spPr>
+          <p:style>
+            <a:lnRef idx="2">
+              <a:schemeClr val="accent1">
+                <a:shade val="15000"/>
+              </a:schemeClr>
+            </a:lnRef>
+            <a:fillRef idx="1">
+              <a:schemeClr val="accent1"/>
+            </a:fillRef>
+            <a:effectRef idx="0">
+              <a:schemeClr val="accent1"/>
+            </a:effectRef>
+            <a:fontRef idx="minor">
+              <a:schemeClr val="lt1"/>
+            </a:fontRef>
+          </p:style>
+          <p:txBody>
+            <a:bodyPr rtlCol="0" anchor="ctr"/>
+            <a:lstStyle/>
+            <a:p>
+              <a:pPr algn="ctr"/>
+              <a:r>
+                <a:rPr lang="en-US" sz="2000" b="1" dirty="0">
+                  <a:solidFill>
+                    <a:schemeClr val="tx2">
+                      <a:lumMod val="50000"/>
+                      <a:lumOff val="50000"/>
+                    </a:schemeClr>
+                  </a:solidFill>
+                </a:rPr>
+                <a:t>riskClient.py</a:t>
+              </a:r>
+            </a:p>
+            <a:p>
+              <a:pPr algn="ctr"/>
+              <a:r>
+                <a:rPr lang="en-US" b="1" dirty="0">
+                  <a:solidFill>
+                    <a:schemeClr val="tx2">
+                      <a:lumMod val="50000"/>
+                      <a:lumOff val="50000"/>
+                    </a:schemeClr>
+                  </a:solidFill>
+                </a:rPr>
+                <a:t>BACKEND</a:t>
+              </a:r>
+              <a:r>
+                <a:rPr lang="en-US" dirty="0">
+                  <a:solidFill>
+                    <a:schemeClr val="tx2">
+                      <a:lumMod val="50000"/>
+                      <a:lumOff val="50000"/>
+                    </a:schemeClr>
+                  </a:solidFill>
+                </a:rPr>
+                <a:t> </a:t>
+              </a:r>
+              <a:r>
+                <a:rPr lang="en-US" i="1" dirty="0">
+                  <a:solidFill>
+                    <a:schemeClr val="tx2">
+                      <a:lumMod val="50000"/>
+                      <a:lumOff val="50000"/>
+                    </a:schemeClr>
+                  </a:solidFill>
+                </a:rPr>
+                <a:t>logic for data analysis, output structuring, RAG DB</a:t>
+              </a:r>
+            </a:p>
+          </p:txBody>
+        </p:sp>
+        <p:sp>
+          <p:nvSpPr>
+            <p:cNvPr id="10" name="Arrow: Right 9">
+              <a:extLst>
+                <a:ext uri="{FF2B5EF4-FFF2-40B4-BE49-F238E27FC236}">
+                  <a16:creationId xmlns:a16="http://schemas.microsoft.com/office/drawing/2014/main" id="{3A57EEFC-8AEF-063F-FCAC-25FA2E436394}"/>
+                </a:ext>
+              </a:extLst>
+            </p:cNvPr>
+            <p:cNvSpPr/>
+            <p:nvPr/>
+          </p:nvSpPr>
+          <p:spPr>
+            <a:xfrm>
+              <a:off x="3737550" y="3513867"/>
+              <a:ext cx="1066007" cy="865761"/>
+            </a:xfrm>
+            <a:prstGeom prst="rightArrow">
+              <a:avLst/>
+            </a:prstGeom>
+            <a:solidFill>
+              <a:schemeClr val="tx2">
+                <a:lumMod val="25000"/>
+                <a:lumOff val="75000"/>
+              </a:schemeClr>
+            </a:solidFill>
+            <a:ln>
+              <a:solidFill>
+                <a:schemeClr val="tx2">
+                  <a:lumMod val="50000"/>
+                  <a:lumOff val="50000"/>
+                </a:schemeClr>
+              </a:solidFill>
+            </a:ln>
+          </p:spPr>
+          <p:style>
+            <a:lnRef idx="2">
+              <a:schemeClr val="accent1">
+                <a:shade val="15000"/>
+              </a:schemeClr>
+            </a:lnRef>
+            <a:fillRef idx="1">
+              <a:schemeClr val="accent1"/>
+            </a:fillRef>
+            <a:effectRef idx="0">
+              <a:schemeClr val="accent1"/>
+            </a:effectRef>
+            <a:fontRef idx="minor">
+              <a:schemeClr val="lt1"/>
+            </a:fontRef>
+          </p:style>
+          <p:txBody>
+            <a:bodyPr rtlCol="0" anchor="ctr"/>
+            <a:lstStyle/>
+            <a:p>
+              <a:pPr algn="ctr"/>
+              <a:endParaRPr lang="en-US"/>
+            </a:p>
+          </p:txBody>
+        </p:sp>
+        <p:sp>
+          <p:nvSpPr>
+            <p:cNvPr id="11" name="Arrow: Right 10">
+              <a:extLst>
+                <a:ext uri="{FF2B5EF4-FFF2-40B4-BE49-F238E27FC236}">
+                  <a16:creationId xmlns:a16="http://schemas.microsoft.com/office/drawing/2014/main" id="{714F1514-EE82-B1FA-F701-AB38E2F5A007}"/>
+                </a:ext>
+              </a:extLst>
+            </p:cNvPr>
+            <p:cNvSpPr/>
+            <p:nvPr/>
+          </p:nvSpPr>
+          <p:spPr>
+            <a:xfrm>
+              <a:off x="7314881" y="3513867"/>
+              <a:ext cx="1066007" cy="865761"/>
+            </a:xfrm>
+            <a:prstGeom prst="rightArrow">
+              <a:avLst/>
+            </a:prstGeom>
+            <a:solidFill>
+              <a:schemeClr val="tx2">
+                <a:lumMod val="25000"/>
+                <a:lumOff val="75000"/>
+              </a:schemeClr>
+            </a:solidFill>
+            <a:ln>
+              <a:solidFill>
+                <a:schemeClr val="tx2">
+                  <a:lumMod val="50000"/>
+                  <a:lumOff val="50000"/>
+                </a:schemeClr>
+              </a:solidFill>
+            </a:ln>
+          </p:spPr>
+          <p:style>
+            <a:lnRef idx="2">
+              <a:schemeClr val="accent1">
+                <a:shade val="15000"/>
+              </a:schemeClr>
+            </a:lnRef>
+            <a:fillRef idx="1">
+              <a:schemeClr val="accent1"/>
+            </a:fillRef>
+            <a:effectRef idx="0">
+              <a:schemeClr val="accent1"/>
+            </a:effectRef>
+            <a:fontRef idx="minor">
+              <a:schemeClr val="lt1"/>
+            </a:fontRef>
+          </p:style>
+          <p:txBody>
+            <a:bodyPr rtlCol="0" anchor="ctr"/>
+            <a:lstStyle/>
+            <a:p>
+              <a:pPr algn="ctr"/>
+              <a:endParaRPr lang="en-US"/>
+            </a:p>
+          </p:txBody>
+        </p:sp>
+        <p:sp>
+          <p:nvSpPr>
+            <p:cNvPr id="14" name="Arrow: Bent 13">
+              <a:extLst>
+                <a:ext uri="{FF2B5EF4-FFF2-40B4-BE49-F238E27FC236}">
+                  <a16:creationId xmlns:a16="http://schemas.microsoft.com/office/drawing/2014/main" id="{09630D37-F4D3-7B69-4C7C-2F69362D7B75}"/>
+                </a:ext>
+              </a:extLst>
+            </p:cNvPr>
+            <p:cNvSpPr/>
+            <p:nvPr/>
+          </p:nvSpPr>
+          <p:spPr>
+            <a:xfrm rot="10800000">
+              <a:off x="9550164" y="1223977"/>
+              <a:ext cx="788983" cy="2127238"/>
+            </a:xfrm>
+            <a:prstGeom prst="bentArrow">
+              <a:avLst>
+                <a:gd name="adj1" fmla="val 11420"/>
+                <a:gd name="adj2" fmla="val 25000"/>
+                <a:gd name="adj3" fmla="val 25000"/>
+                <a:gd name="adj4" fmla="val 43750"/>
+              </a:avLst>
+            </a:prstGeom>
+            <a:solidFill>
+              <a:schemeClr val="tx2">
+                <a:lumMod val="25000"/>
+                <a:lumOff val="75000"/>
+              </a:schemeClr>
+            </a:solidFill>
+            <a:ln>
+              <a:solidFill>
+                <a:schemeClr val="tx2">
+                  <a:lumMod val="50000"/>
+                  <a:lumOff val="50000"/>
+                </a:schemeClr>
+              </a:solidFill>
+            </a:ln>
+          </p:spPr>
+          <p:style>
+            <a:lnRef idx="2">
+              <a:schemeClr val="accent1">
+                <a:shade val="15000"/>
+              </a:schemeClr>
+            </a:lnRef>
+            <a:fillRef idx="1">
+              <a:schemeClr val="accent1"/>
+            </a:fillRef>
+            <a:effectRef idx="0">
+              <a:schemeClr val="accent1"/>
+            </a:effectRef>
+            <a:fontRef idx="minor">
+              <a:schemeClr val="lt1"/>
+            </a:fontRef>
+          </p:style>
+          <p:txBody>
+            <a:bodyPr rtlCol="0" anchor="ctr"/>
+            <a:lstStyle/>
+            <a:p>
+              <a:pPr algn="ctr"/>
+              <a:endParaRPr lang="en-US">
+                <a:solidFill>
+                  <a:schemeClr val="tx1"/>
+                </a:solidFill>
+              </a:endParaRPr>
+            </a:p>
+          </p:txBody>
+        </p:sp>
+        <p:sp>
+          <p:nvSpPr>
+            <p:cNvPr id="28" name="Arrow: Bent 27">
+              <a:extLst>
+                <a:ext uri="{FF2B5EF4-FFF2-40B4-BE49-F238E27FC236}">
+                  <a16:creationId xmlns:a16="http://schemas.microsoft.com/office/drawing/2014/main" id="{2B6406A8-4F16-CA73-73D9-8FBFCB75C973}"/>
+                </a:ext>
+              </a:extLst>
+            </p:cNvPr>
+            <p:cNvSpPr/>
+            <p:nvPr/>
+          </p:nvSpPr>
+          <p:spPr>
+            <a:xfrm rot="10800000">
+              <a:off x="10954558" y="1018687"/>
+              <a:ext cx="788983" cy="2127238"/>
+            </a:xfrm>
+            <a:prstGeom prst="bentArrow">
+              <a:avLst>
+                <a:gd name="adj1" fmla="val 11420"/>
+                <a:gd name="adj2" fmla="val 25000"/>
+                <a:gd name="adj3" fmla="val 25000"/>
+                <a:gd name="adj4" fmla="val 43750"/>
+              </a:avLst>
+            </a:prstGeom>
+            <a:solidFill>
+              <a:schemeClr val="accent1">
+                <a:lumMod val="40000"/>
+                <a:lumOff val="60000"/>
+              </a:schemeClr>
+            </a:solidFill>
+            <a:ln>
+              <a:solidFill>
+                <a:schemeClr val="tx2">
+                  <a:lumMod val="50000"/>
+                  <a:lumOff val="50000"/>
+                </a:schemeClr>
+              </a:solidFill>
+            </a:ln>
+          </p:spPr>
+          <p:style>
+            <a:lnRef idx="2">
+              <a:schemeClr val="accent1">
+                <a:shade val="15000"/>
+              </a:schemeClr>
+            </a:lnRef>
+            <a:fillRef idx="1">
+              <a:schemeClr val="accent1"/>
+            </a:fillRef>
+            <a:effectRef idx="0">
+              <a:schemeClr val="accent1"/>
+            </a:effectRef>
+            <a:fontRef idx="minor">
+              <a:schemeClr val="lt1"/>
+            </a:fontRef>
+          </p:style>
+          <p:txBody>
+            <a:bodyPr rtlCol="0" anchor="ctr"/>
+            <a:lstStyle/>
+            <a:p>
+              <a:pPr algn="ctr"/>
+              <a:endParaRPr lang="en-US">
+                <a:solidFill>
+                  <a:schemeClr val="tx1"/>
+                </a:solidFill>
+              </a:endParaRPr>
+            </a:p>
+          </p:txBody>
+        </p:sp>
+        <p:sp>
+          <p:nvSpPr>
+            <p:cNvPr id="12" name="Rectangle 11">
+              <a:extLst>
+                <a:ext uri="{FF2B5EF4-FFF2-40B4-BE49-F238E27FC236}">
+                  <a16:creationId xmlns:a16="http://schemas.microsoft.com/office/drawing/2014/main" id="{C3598AFF-E445-A6D4-0A5F-92B6526C6AA9}"/>
+                </a:ext>
+              </a:extLst>
+            </p:cNvPr>
+            <p:cNvSpPr/>
+            <p:nvPr/>
+          </p:nvSpPr>
+          <p:spPr>
+            <a:xfrm>
+              <a:off x="10575701" y="130908"/>
+              <a:ext cx="1546698" cy="515566"/>
+            </a:xfrm>
+            <a:prstGeom prst="rect">
+              <a:avLst/>
+            </a:prstGeom>
+            <a:solidFill>
+              <a:schemeClr val="tx2">
+                <a:lumMod val="50000"/>
+                <a:lumOff val="50000"/>
+              </a:schemeClr>
+            </a:solidFill>
+            <a:ln>
+              <a:solidFill>
+                <a:schemeClr val="tx2">
+                  <a:lumMod val="50000"/>
+                  <a:lumOff val="50000"/>
+                </a:schemeClr>
+              </a:solidFill>
+            </a:ln>
+          </p:spPr>
+          <p:style>
+            <a:lnRef idx="2">
+              <a:schemeClr val="accent1">
+                <a:shade val="15000"/>
+              </a:schemeClr>
+            </a:lnRef>
+            <a:fillRef idx="1">
+              <a:schemeClr val="accent1"/>
+            </a:fillRef>
+            <a:effectRef idx="0">
+              <a:schemeClr val="accent1"/>
+            </a:effectRef>
+            <a:fontRef idx="minor">
+              <a:schemeClr val="lt1"/>
+            </a:fontRef>
+          </p:style>
+          <p:txBody>
+            <a:bodyPr rtlCol="0" anchor="ctr"/>
+            <a:lstStyle/>
+            <a:p>
+              <a:pPr algn="ctr"/>
+              <a:r>
+                <a:rPr lang="en-US" b="1" dirty="0"/>
+                <a:t>USER</a:t>
+              </a:r>
+            </a:p>
+          </p:txBody>
+        </p:sp>
+        <p:sp>
+          <p:nvSpPr>
+            <p:cNvPr id="17" name="Arrow: Left 16">
+              <a:extLst>
+                <a:ext uri="{FF2B5EF4-FFF2-40B4-BE49-F238E27FC236}">
+                  <a16:creationId xmlns:a16="http://schemas.microsoft.com/office/drawing/2014/main" id="{870AB055-98F4-A6D1-D4F3-27A8F6821E02}"/>
+                </a:ext>
+              </a:extLst>
+            </p:cNvPr>
+            <p:cNvSpPr/>
+            <p:nvPr/>
+          </p:nvSpPr>
+          <p:spPr>
+            <a:xfrm>
+              <a:off x="6135880" y="2992288"/>
+              <a:ext cx="3241758" cy="321014"/>
+            </a:xfrm>
+            <a:prstGeom prst="leftArrow">
+              <a:avLst>
+                <a:gd name="adj1" fmla="val 25757"/>
+                <a:gd name="adj2" fmla="val 50000"/>
+              </a:avLst>
+            </a:prstGeom>
+            <a:solidFill>
+              <a:schemeClr val="tx2">
+                <a:lumMod val="25000"/>
+                <a:lumOff val="75000"/>
+              </a:schemeClr>
+            </a:solidFill>
+            <a:ln>
+              <a:solidFill>
+                <a:schemeClr val="tx2">
+                  <a:lumMod val="50000"/>
+                  <a:lumOff val="50000"/>
+                </a:schemeClr>
+              </a:solidFill>
+            </a:ln>
+          </p:spPr>
+          <p:style>
+            <a:lnRef idx="2">
+              <a:schemeClr val="accent1">
+                <a:shade val="15000"/>
+              </a:schemeClr>
+            </a:lnRef>
+            <a:fillRef idx="1">
+              <a:schemeClr val="accent1"/>
+            </a:fillRef>
+            <a:effectRef idx="0">
+              <a:schemeClr val="accent1"/>
+            </a:effectRef>
+            <a:fontRef idx="minor">
+              <a:schemeClr val="lt1"/>
+            </a:fontRef>
+          </p:style>
+          <p:txBody>
+            <a:bodyPr rtlCol="0" anchor="ctr"/>
+            <a:lstStyle/>
+            <a:p>
+              <a:pPr algn="ctr"/>
+              <a:endParaRPr lang="en-US"/>
+            </a:p>
+          </p:txBody>
+        </p:sp>
+        <p:sp>
+          <p:nvSpPr>
+            <p:cNvPr id="22" name="Rectangle: Rounded Corners 21">
+              <a:extLst>
+                <a:ext uri="{FF2B5EF4-FFF2-40B4-BE49-F238E27FC236}">
+                  <a16:creationId xmlns:a16="http://schemas.microsoft.com/office/drawing/2014/main" id="{ABCD2F8C-A613-D80C-535A-216BB002F22B}"/>
+                </a:ext>
+              </a:extLst>
+            </p:cNvPr>
+            <p:cNvSpPr/>
+            <p:nvPr/>
+          </p:nvSpPr>
+          <p:spPr>
+            <a:xfrm>
+              <a:off x="3562060" y="15156"/>
+              <a:ext cx="4389950" cy="1768174"/>
+            </a:xfrm>
+            <a:prstGeom prst="roundRect">
+              <a:avLst/>
+            </a:prstGeom>
+            <a:solidFill>
+              <a:schemeClr val="tx2">
+                <a:lumMod val="25000"/>
+                <a:lumOff val="75000"/>
+              </a:schemeClr>
+            </a:solidFill>
+            <a:ln>
+              <a:solidFill>
+                <a:schemeClr val="tx2">
+                  <a:lumMod val="50000"/>
+                  <a:lumOff val="50000"/>
+                </a:schemeClr>
+              </a:solidFill>
+            </a:ln>
+          </p:spPr>
+          <p:style>
+            <a:lnRef idx="2">
+              <a:schemeClr val="accent1">
+                <a:shade val="15000"/>
+              </a:schemeClr>
+            </a:lnRef>
+            <a:fillRef idx="1">
+              <a:schemeClr val="accent1"/>
+            </a:fillRef>
+            <a:effectRef idx="0">
+              <a:schemeClr val="accent1"/>
+            </a:effectRef>
+            <a:fontRef idx="minor">
+              <a:schemeClr val="lt1"/>
+            </a:fontRef>
+          </p:style>
+          <p:txBody>
+            <a:bodyPr rtlCol="0" anchor="ctr"/>
+            <a:lstStyle/>
+            <a:p>
+              <a:pPr algn="ctr"/>
+              <a:endParaRPr lang="en-US"/>
+            </a:p>
+          </p:txBody>
+        </p:sp>
+        <p:sp>
+          <p:nvSpPr>
+            <p:cNvPr id="18" name="Arrow: U-Turn 17">
+              <a:extLst>
+                <a:ext uri="{FF2B5EF4-FFF2-40B4-BE49-F238E27FC236}">
+                  <a16:creationId xmlns:a16="http://schemas.microsoft.com/office/drawing/2014/main" id="{7B473560-2195-D532-828D-55A46EA77A09}"/>
+                </a:ext>
+              </a:extLst>
+            </p:cNvPr>
+            <p:cNvSpPr/>
+            <p:nvPr/>
+          </p:nvSpPr>
+          <p:spPr>
+            <a:xfrm rot="5400000" flipV="1">
+              <a:off x="109541" y="3172606"/>
+              <a:ext cx="1050584" cy="877080"/>
+            </a:xfrm>
+            <a:prstGeom prst="uturnArrow">
+              <a:avLst>
+                <a:gd name="adj1" fmla="val 13910"/>
+                <a:gd name="adj2" fmla="val 25000"/>
+                <a:gd name="adj3" fmla="val 28327"/>
+                <a:gd name="adj4" fmla="val 43750"/>
+                <a:gd name="adj5" fmla="val 75000"/>
+              </a:avLst>
+            </a:prstGeom>
+            <a:solidFill>
+              <a:schemeClr val="tx2">
+                <a:lumMod val="25000"/>
+                <a:lumOff val="75000"/>
+              </a:schemeClr>
+            </a:solidFill>
+            <a:ln>
+              <a:solidFill>
+                <a:schemeClr val="tx2">
+                  <a:lumMod val="50000"/>
+                  <a:lumOff val="50000"/>
+                </a:schemeClr>
+              </a:solidFill>
+            </a:ln>
+          </p:spPr>
+          <p:style>
+            <a:lnRef idx="2">
+              <a:schemeClr val="accent1">
+                <a:shade val="15000"/>
+              </a:schemeClr>
+            </a:lnRef>
+            <a:fillRef idx="1">
+              <a:schemeClr val="accent1"/>
+            </a:fillRef>
+            <a:effectRef idx="0">
+              <a:schemeClr val="accent1"/>
+            </a:effectRef>
+            <a:fontRef idx="minor">
+              <a:schemeClr val="lt1"/>
+            </a:fontRef>
+          </p:style>
+          <p:txBody>
+            <a:bodyPr rtlCol="0" anchor="ctr"/>
+            <a:lstStyle/>
+            <a:p>
+              <a:pPr algn="ctr"/>
+              <a:endParaRPr lang="en-US">
+                <a:solidFill>
+                  <a:schemeClr val="tx1"/>
+                </a:solidFill>
+              </a:endParaRPr>
+            </a:p>
+          </p:txBody>
+        </p:sp>
+        <p:sp>
+          <p:nvSpPr>
+            <p:cNvPr id="15" name="TextBox 14">
+              <a:extLst>
+                <a:ext uri="{FF2B5EF4-FFF2-40B4-BE49-F238E27FC236}">
+                  <a16:creationId xmlns:a16="http://schemas.microsoft.com/office/drawing/2014/main" id="{02E56FD6-533B-E5D7-5989-BBBA466C86CC}"/>
+                </a:ext>
+              </a:extLst>
+            </p:cNvPr>
+            <p:cNvSpPr txBox="1"/>
+            <p:nvPr/>
+          </p:nvSpPr>
+          <p:spPr>
+            <a:xfrm>
+              <a:off x="10448365" y="1783330"/>
+              <a:ext cx="1546698" cy="923330"/>
+            </a:xfrm>
+            <a:prstGeom prst="rect">
+              <a:avLst/>
+            </a:prstGeom>
+            <a:solidFill>
+              <a:srgbClr val="F2F2F2">
+                <a:alpha val="80000"/>
+              </a:srgbClr>
+            </a:solidFill>
+          </p:spPr>
+          <p:txBody>
+            <a:bodyPr wrap="square" rtlCol="0">
+              <a:spAutoFit/>
+            </a:bodyPr>
+            <a:lstStyle/>
+            <a:p>
+              <a:r>
+                <a:rPr lang="en-US" dirty="0"/>
+                <a:t>Geo query via </a:t>
+              </a:r>
+            </a:p>
+            <a:p>
+              <a:r>
+                <a:rPr lang="en-US" dirty="0"/>
+                <a:t>Map select/ </a:t>
+              </a:r>
+            </a:p>
+            <a:p>
+              <a:r>
+                <a:rPr lang="en-US" dirty="0"/>
+                <a:t>address input</a:t>
+              </a:r>
+            </a:p>
+          </p:txBody>
+        </p:sp>
+        <p:sp>
+          <p:nvSpPr>
+            <p:cNvPr id="19" name="TextBox 18">
+              <a:extLst>
+                <a:ext uri="{FF2B5EF4-FFF2-40B4-BE49-F238E27FC236}">
+                  <a16:creationId xmlns:a16="http://schemas.microsoft.com/office/drawing/2014/main" id="{2E4487B1-4444-2981-CCCD-B73AD52C545B}"/>
+                </a:ext>
+              </a:extLst>
+            </p:cNvPr>
+            <p:cNvSpPr txBox="1"/>
+            <p:nvPr/>
+          </p:nvSpPr>
+          <p:spPr>
+            <a:xfrm>
+              <a:off x="4252532" y="44073"/>
+              <a:ext cx="3389002" cy="1679979"/>
+            </a:xfrm>
+            <a:prstGeom prst="rect">
+              <a:avLst/>
+            </a:prstGeom>
+            <a:solidFill>
+              <a:schemeClr val="tx2">
+                <a:lumMod val="50000"/>
+                <a:lumOff val="50000"/>
+              </a:schemeClr>
+            </a:solidFill>
+            <a:ln>
+              <a:noFill/>
+            </a:ln>
+          </p:spPr>
+          <p:style>
+            <a:lnRef idx="2">
+              <a:schemeClr val="accent1">
+                <a:shade val="15000"/>
+              </a:schemeClr>
+            </a:lnRef>
+            <a:fillRef idx="1">
+              <a:schemeClr val="accent1"/>
+            </a:fillRef>
+            <a:effectRef idx="0">
+              <a:schemeClr val="accent1"/>
+            </a:effectRef>
+            <a:fontRef idx="minor">
+              <a:schemeClr val="lt1"/>
+            </a:fontRef>
+          </p:style>
+          <p:txBody>
+            <a:bodyPr rtlCol="0" anchor="ctr"/>
+            <a:lstStyle>
+              <a:defPPr>
+                <a:defRPr lang="en-US"/>
+              </a:defPPr>
+              <a:lvl1pPr algn="ctr">
+                <a:defRPr b="1">
+                  <a:solidFill>
+                    <a:schemeClr val="lt1"/>
+                  </a:solidFill>
+                </a:defRPr>
+              </a:lvl1pPr>
+              <a:lvl2pPr>
+                <a:defRPr>
+                  <a:solidFill>
+                    <a:schemeClr val="lt1"/>
+                  </a:solidFill>
+                </a:defRPr>
+              </a:lvl2pPr>
+              <a:lvl3pPr>
+                <a:defRPr>
+                  <a:solidFill>
+                    <a:schemeClr val="lt1"/>
+                  </a:solidFill>
+                </a:defRPr>
+              </a:lvl3pPr>
+              <a:lvl4pPr>
+                <a:defRPr>
+                  <a:solidFill>
+                    <a:schemeClr val="lt1"/>
+                  </a:solidFill>
+                </a:defRPr>
+              </a:lvl4pPr>
+              <a:lvl5pPr>
+                <a:defRPr>
+                  <a:solidFill>
+                    <a:schemeClr val="lt1"/>
+                  </a:solidFill>
+                </a:defRPr>
+              </a:lvl5pPr>
+              <a:lvl6pPr>
+                <a:defRPr>
+                  <a:solidFill>
+                    <a:schemeClr val="lt1"/>
+                  </a:solidFill>
+                </a:defRPr>
+              </a:lvl6pPr>
+              <a:lvl7pPr>
+                <a:defRPr>
+                  <a:solidFill>
+                    <a:schemeClr val="lt1"/>
+                  </a:solidFill>
+                </a:defRPr>
+              </a:lvl7pPr>
+              <a:lvl8pPr>
+                <a:defRPr>
+                  <a:solidFill>
+                    <a:schemeClr val="lt1"/>
+                  </a:solidFill>
+                </a:defRPr>
+              </a:lvl8pPr>
+              <a:lvl9pPr>
+                <a:defRPr>
+                  <a:solidFill>
+                    <a:schemeClr val="lt1"/>
+                  </a:solidFill>
+                </a:defRPr>
+              </a:lvl9pPr>
+            </a:lstStyle>
+            <a:p>
+              <a:pPr algn="l"/>
+              <a:r>
+                <a:rPr lang="en-US" sz="1300" dirty="0"/>
+                <a:t>QUERYABLE SERVICES</a:t>
+              </a:r>
+            </a:p>
+            <a:p>
+              <a:pPr marL="285750" indent="-285750" algn="l">
+                <a:buFont typeface="+mj-lt"/>
+                <a:buAutoNum type="arabicPeriod"/>
+              </a:pPr>
+              <a:r>
+                <a:rPr lang="en-US" sz="1300" dirty="0"/>
+                <a:t>Fire hazard service </a:t>
+              </a:r>
+              <a:r>
+                <a:rPr lang="en-US" sz="1300" b="0" dirty="0"/>
+                <a:t>(hazard zones)</a:t>
+              </a:r>
+            </a:p>
+            <a:p>
+              <a:pPr marL="285750" indent="-285750" algn="l">
+                <a:buFont typeface="+mj-lt"/>
+                <a:buAutoNum type="arabicPeriod"/>
+              </a:pPr>
+              <a:r>
+                <a:rPr lang="en-US" sz="1300" dirty="0" err="1"/>
+                <a:t>zhvi</a:t>
+              </a:r>
+              <a:r>
+                <a:rPr lang="en-US" sz="1300" dirty="0"/>
+                <a:t> service </a:t>
+              </a:r>
+              <a:r>
+                <a:rPr lang="en-US" sz="1300" b="0" dirty="0"/>
+                <a:t>(Zillow home values)</a:t>
+              </a:r>
+            </a:p>
+            <a:p>
+              <a:pPr marL="285750" indent="-285750" algn="l">
+                <a:buFont typeface="+mj-lt"/>
+                <a:buAutoNum type="arabicPeriod"/>
+              </a:pPr>
+              <a:r>
+                <a:rPr lang="en-US" sz="1300" dirty="0"/>
+                <a:t>Fire history service </a:t>
+              </a:r>
+              <a:r>
+                <a:rPr lang="en-US" sz="1300" b="0" dirty="0"/>
+                <a:t>(historic fire events)</a:t>
+              </a:r>
+            </a:p>
+            <a:p>
+              <a:pPr marL="285750" indent="-285750" algn="l">
+                <a:buFont typeface="+mj-lt"/>
+                <a:buAutoNum type="arabicPeriod"/>
+              </a:pPr>
+              <a:r>
+                <a:rPr lang="en-US" sz="1300" dirty="0"/>
+                <a:t>Damage inspection service</a:t>
+              </a:r>
+            </a:p>
+            <a:p>
+              <a:pPr algn="l"/>
+              <a:r>
+                <a:rPr lang="en-US" sz="1300" b="0" dirty="0"/>
+                <a:t>        (proximity to fire-damaged structures +</a:t>
+              </a:r>
+            </a:p>
+            <a:p>
+              <a:pPr algn="l"/>
+              <a:r>
+                <a:rPr lang="en-US" sz="1300" b="0" dirty="0"/>
+                <a:t>         characteristics)</a:t>
+              </a:r>
+            </a:p>
+            <a:p>
+              <a:pPr algn="l"/>
+              <a:r>
+                <a:rPr lang="en-US" sz="1300" dirty="0"/>
+                <a:t>5.    DOI service </a:t>
+              </a:r>
+              <a:r>
+                <a:rPr lang="en-US" sz="1300" b="0" dirty="0"/>
+                <a:t>(Insurance renewal)</a:t>
+              </a:r>
+            </a:p>
+          </p:txBody>
+        </p:sp>
+        <p:sp>
+          <p:nvSpPr>
+            <p:cNvPr id="26" name="Arrow: Left 25">
+              <a:extLst>
+                <a:ext uri="{FF2B5EF4-FFF2-40B4-BE49-F238E27FC236}">
+                  <a16:creationId xmlns:a16="http://schemas.microsoft.com/office/drawing/2014/main" id="{778A5ADD-B728-85A3-6C35-6DAEBC97C164}"/>
+                </a:ext>
+              </a:extLst>
+            </p:cNvPr>
+            <p:cNvSpPr/>
+            <p:nvPr/>
+          </p:nvSpPr>
+          <p:spPr>
+            <a:xfrm>
+              <a:off x="1165148" y="2949314"/>
+              <a:ext cx="4643338" cy="378425"/>
+            </a:xfrm>
+            <a:prstGeom prst="leftArrow">
+              <a:avLst>
+                <a:gd name="adj1" fmla="val 25757"/>
+                <a:gd name="adj2" fmla="val 50000"/>
+              </a:avLst>
+            </a:prstGeom>
+            <a:solidFill>
+              <a:schemeClr val="tx2">
+                <a:lumMod val="25000"/>
+                <a:lumOff val="75000"/>
+              </a:schemeClr>
+            </a:solidFill>
+            <a:ln>
+              <a:solidFill>
+                <a:schemeClr val="tx2">
+                  <a:lumMod val="50000"/>
+                  <a:lumOff val="50000"/>
+                </a:schemeClr>
+              </a:solidFill>
+            </a:ln>
+          </p:spPr>
+          <p:style>
+            <a:lnRef idx="2">
+              <a:schemeClr val="accent1">
+                <a:shade val="15000"/>
+              </a:schemeClr>
+            </a:lnRef>
+            <a:fillRef idx="1">
+              <a:schemeClr val="accent1"/>
+            </a:fillRef>
+            <a:effectRef idx="0">
+              <a:schemeClr val="accent1"/>
+            </a:effectRef>
+            <a:fontRef idx="minor">
+              <a:schemeClr val="lt1"/>
+            </a:fontRef>
+          </p:style>
+          <p:txBody>
+            <a:bodyPr rtlCol="0" anchor="ctr"/>
+            <a:lstStyle/>
+            <a:p>
+              <a:pPr algn="ctr"/>
+              <a:endParaRPr lang="en-US"/>
+            </a:p>
+          </p:txBody>
+        </p:sp>
+        <p:sp>
+          <p:nvSpPr>
+            <p:cNvPr id="23" name="Arrow: Down 22">
+              <a:extLst>
+                <a:ext uri="{FF2B5EF4-FFF2-40B4-BE49-F238E27FC236}">
+                  <a16:creationId xmlns:a16="http://schemas.microsoft.com/office/drawing/2014/main" id="{D8DE2861-44FB-F8EB-69A2-826F5F0CCFC7}"/>
+                </a:ext>
+              </a:extLst>
+            </p:cNvPr>
+            <p:cNvSpPr/>
+            <p:nvPr/>
+          </p:nvSpPr>
+          <p:spPr>
+            <a:xfrm>
+              <a:off x="5228789" y="1783331"/>
+              <a:ext cx="1234284" cy="1302523"/>
+            </a:xfrm>
+            <a:prstGeom prst="downArrow">
+              <a:avLst/>
+            </a:prstGeom>
+            <a:solidFill>
+              <a:schemeClr val="tx2">
+                <a:lumMod val="25000"/>
+                <a:lumOff val="75000"/>
+              </a:schemeClr>
+            </a:solidFill>
+            <a:ln>
+              <a:solidFill>
+                <a:schemeClr val="tx2">
+                  <a:lumMod val="25000"/>
+                  <a:lumOff val="75000"/>
+                </a:schemeClr>
+              </a:solidFill>
+            </a:ln>
+          </p:spPr>
+          <p:style>
+            <a:lnRef idx="2">
+              <a:schemeClr val="accent1">
+                <a:shade val="15000"/>
+              </a:schemeClr>
+            </a:lnRef>
+            <a:fillRef idx="1">
+              <a:schemeClr val="accent1"/>
+            </a:fillRef>
+            <a:effectRef idx="0">
+              <a:schemeClr val="accent1"/>
+            </a:effectRef>
+            <a:fontRef idx="minor">
+              <a:schemeClr val="lt1"/>
+            </a:fontRef>
+          </p:style>
+          <p:txBody>
+            <a:bodyPr rtlCol="0" anchor="ctr"/>
+            <a:lstStyle/>
+            <a:p>
+              <a:pPr algn="ctr"/>
+              <a:endParaRPr lang="en-US"/>
+            </a:p>
+          </p:txBody>
+        </p:sp>
+        <p:sp>
+          <p:nvSpPr>
+            <p:cNvPr id="25" name="TextBox 24">
+              <a:extLst>
+                <a:ext uri="{FF2B5EF4-FFF2-40B4-BE49-F238E27FC236}">
+                  <a16:creationId xmlns:a16="http://schemas.microsoft.com/office/drawing/2014/main" id="{9C195112-6E1C-DC61-DDEA-D0F2861194AD}"/>
+                </a:ext>
+              </a:extLst>
+            </p:cNvPr>
+            <p:cNvSpPr txBox="1"/>
+            <p:nvPr/>
+          </p:nvSpPr>
+          <p:spPr>
+            <a:xfrm>
+              <a:off x="4925622" y="1890855"/>
+              <a:ext cx="1932376" cy="448123"/>
+            </a:xfrm>
+            <a:prstGeom prst="rect">
+              <a:avLst/>
+            </a:prstGeom>
+            <a:solidFill>
+              <a:schemeClr val="tx2">
+                <a:lumMod val="10000"/>
+                <a:lumOff val="90000"/>
+              </a:schemeClr>
+            </a:solidFill>
+            <a:ln>
+              <a:solidFill>
+                <a:schemeClr val="tx2">
+                  <a:lumMod val="10000"/>
+                  <a:lumOff val="90000"/>
+                </a:schemeClr>
+              </a:solidFill>
+            </a:ln>
+          </p:spPr>
+          <p:style>
+            <a:lnRef idx="2">
+              <a:schemeClr val="accent1">
+                <a:shade val="15000"/>
+              </a:schemeClr>
+            </a:lnRef>
+            <a:fillRef idx="1">
+              <a:schemeClr val="accent1"/>
+            </a:fillRef>
+            <a:effectRef idx="0">
+              <a:schemeClr val="accent1"/>
+            </a:effectRef>
+            <a:fontRef idx="minor">
+              <a:schemeClr val="lt1"/>
+            </a:fontRef>
+          </p:style>
+          <p:txBody>
+            <a:bodyPr rtlCol="0" anchor="ctr"/>
+            <a:lstStyle>
+              <a:defPPr>
+                <a:defRPr lang="en-US"/>
+              </a:defPPr>
+              <a:lvl1pPr algn="ctr">
+                <a:defRPr b="1">
+                  <a:solidFill>
+                    <a:schemeClr val="lt1"/>
+                  </a:solidFill>
+                </a:defRPr>
+              </a:lvl1pPr>
+              <a:lvl2pPr>
+                <a:defRPr>
+                  <a:solidFill>
+                    <a:schemeClr val="lt1"/>
+                  </a:solidFill>
+                </a:defRPr>
+              </a:lvl2pPr>
+              <a:lvl3pPr>
+                <a:defRPr>
+                  <a:solidFill>
+                    <a:schemeClr val="lt1"/>
+                  </a:solidFill>
+                </a:defRPr>
+              </a:lvl3pPr>
+              <a:lvl4pPr>
+                <a:defRPr>
+                  <a:solidFill>
+                    <a:schemeClr val="lt1"/>
+                  </a:solidFill>
+                </a:defRPr>
+              </a:lvl4pPr>
+              <a:lvl5pPr>
+                <a:defRPr>
+                  <a:solidFill>
+                    <a:schemeClr val="lt1"/>
+                  </a:solidFill>
+                </a:defRPr>
+              </a:lvl5pPr>
+              <a:lvl6pPr>
+                <a:defRPr>
+                  <a:solidFill>
+                    <a:schemeClr val="lt1"/>
+                  </a:solidFill>
+                </a:defRPr>
+              </a:lvl6pPr>
+              <a:lvl7pPr>
+                <a:defRPr>
+                  <a:solidFill>
+                    <a:schemeClr val="lt1"/>
+                  </a:solidFill>
+                </a:defRPr>
+              </a:lvl7pPr>
+              <a:lvl8pPr>
+                <a:defRPr>
+                  <a:solidFill>
+                    <a:schemeClr val="lt1"/>
+                  </a:solidFill>
+                </a:defRPr>
+              </a:lvl8pPr>
+              <a:lvl9pPr>
+                <a:defRPr>
+                  <a:solidFill>
+                    <a:schemeClr val="lt1"/>
+                  </a:solidFill>
+                </a:defRPr>
+              </a:lvl9pPr>
+            </a:lstStyle>
+            <a:p>
+              <a:r>
+                <a:rPr lang="en-US" dirty="0">
+                  <a:solidFill>
+                    <a:schemeClr val="tx2">
+                      <a:lumMod val="75000"/>
+                      <a:lumOff val="25000"/>
+                    </a:schemeClr>
+                  </a:solidFill>
+                </a:rPr>
+                <a:t>Trend Analysis</a:t>
+              </a:r>
+            </a:p>
+          </p:txBody>
+        </p:sp>
+        <p:sp>
+          <p:nvSpPr>
+            <p:cNvPr id="2" name="Rectangle: Rounded Corners 1">
+              <a:extLst>
+                <a:ext uri="{FF2B5EF4-FFF2-40B4-BE49-F238E27FC236}">
+                  <a16:creationId xmlns:a16="http://schemas.microsoft.com/office/drawing/2014/main" id="{A301D6EA-C26C-E7D4-94F4-B43FEAB67FB6}"/>
+                </a:ext>
+              </a:extLst>
+            </p:cNvPr>
+            <p:cNvSpPr/>
+            <p:nvPr/>
+          </p:nvSpPr>
+          <p:spPr>
+            <a:xfrm>
+              <a:off x="1165148" y="5020652"/>
+              <a:ext cx="2945034" cy="1768174"/>
+            </a:xfrm>
+            <a:prstGeom prst="roundRect">
+              <a:avLst/>
+            </a:prstGeom>
+            <a:solidFill>
+              <a:schemeClr val="tx2">
+                <a:lumMod val="25000"/>
+                <a:lumOff val="75000"/>
+              </a:schemeClr>
+            </a:solidFill>
+            <a:ln>
+              <a:solidFill>
+                <a:schemeClr val="tx2">
+                  <a:lumMod val="50000"/>
+                  <a:lumOff val="50000"/>
+                </a:schemeClr>
+              </a:solidFill>
+            </a:ln>
+          </p:spPr>
+          <p:style>
+            <a:lnRef idx="2">
+              <a:schemeClr val="accent1">
+                <a:shade val="15000"/>
+              </a:schemeClr>
+            </a:lnRef>
+            <a:fillRef idx="1">
+              <a:schemeClr val="accent1"/>
+            </a:fillRef>
+            <a:effectRef idx="0">
+              <a:schemeClr val="accent1"/>
+            </a:effectRef>
+            <a:fontRef idx="minor">
+              <a:schemeClr val="lt1"/>
+            </a:fontRef>
+          </p:style>
+          <p:txBody>
+            <a:bodyPr rtlCol="0" anchor="ctr"/>
+            <a:lstStyle/>
+            <a:p>
+              <a:pPr algn="ctr"/>
+              <a:r>
+                <a:rPr lang="en-US" sz="1700" b="1" dirty="0">
+                  <a:solidFill>
+                    <a:schemeClr val="tx2"/>
+                  </a:solidFill>
+                </a:rPr>
+                <a:t>RAG DATABASE</a:t>
+              </a:r>
+            </a:p>
+            <a:p>
+              <a:pPr marL="285750" indent="-285750">
+                <a:buFontTx/>
+                <a:buChar char="-"/>
+              </a:pPr>
+              <a:r>
+                <a:rPr lang="en-US" sz="1700" dirty="0" err="1">
+                  <a:solidFill>
+                    <a:schemeClr val="tx2"/>
+                  </a:solidFill>
+                </a:rPr>
+                <a:t>FairPlan</a:t>
+              </a:r>
+              <a:r>
+                <a:rPr lang="en-US" sz="1700" dirty="0">
+                  <a:solidFill>
+                    <a:schemeClr val="tx2"/>
+                  </a:solidFill>
+                </a:rPr>
+                <a:t>/ insurance docs</a:t>
+              </a:r>
+            </a:p>
+            <a:p>
+              <a:pPr marL="285750" indent="-285750">
+                <a:buFontTx/>
+                <a:buChar char="-"/>
+              </a:pPr>
+              <a:r>
+                <a:rPr lang="en-US" sz="1700" dirty="0">
+                  <a:solidFill>
+                    <a:schemeClr val="tx2"/>
+                  </a:solidFill>
+                </a:rPr>
+                <a:t>Home hardening info/recs</a:t>
+              </a:r>
+            </a:p>
+            <a:p>
+              <a:pPr marL="285750" indent="-285750">
+                <a:buFontTx/>
+                <a:buChar char="-"/>
+              </a:pPr>
+              <a:r>
+                <a:rPr lang="en-US" sz="1700" dirty="0">
+                  <a:solidFill>
+                    <a:schemeClr val="tx2"/>
+                  </a:solidFill>
+                </a:rPr>
+                <a:t>Wildfire safety docs</a:t>
+              </a:r>
+            </a:p>
+            <a:p>
+              <a:endParaRPr lang="en-US" sz="1700" dirty="0">
+                <a:solidFill>
+                  <a:schemeClr val="tx2"/>
+                </a:solidFill>
+              </a:endParaRPr>
+            </a:p>
+          </p:txBody>
+        </p:sp>
+        <p:sp>
+          <p:nvSpPr>
+            <p:cNvPr id="3" name="TextBox 2">
+              <a:extLst>
+                <a:ext uri="{FF2B5EF4-FFF2-40B4-BE49-F238E27FC236}">
+                  <a16:creationId xmlns:a16="http://schemas.microsoft.com/office/drawing/2014/main" id="{139F73C6-178C-69A2-86A2-28F7090CCFF1}"/>
+                </a:ext>
+              </a:extLst>
+            </p:cNvPr>
+            <p:cNvSpPr txBox="1"/>
+            <p:nvPr/>
+          </p:nvSpPr>
+          <p:spPr>
+            <a:xfrm>
+              <a:off x="9910618" y="775854"/>
+              <a:ext cx="960580" cy="448123"/>
+            </a:xfrm>
+            <a:prstGeom prst="rect">
+              <a:avLst/>
+            </a:prstGeom>
+            <a:solidFill>
+              <a:schemeClr val="tx2">
+                <a:lumMod val="10000"/>
+                <a:lumOff val="90000"/>
+              </a:schemeClr>
+            </a:solidFill>
+            <a:ln>
+              <a:solidFill>
+                <a:schemeClr val="tx2">
+                  <a:lumMod val="10000"/>
+                  <a:lumOff val="90000"/>
+                </a:schemeClr>
+              </a:solidFill>
+            </a:ln>
+          </p:spPr>
+          <p:style>
+            <a:lnRef idx="2">
+              <a:schemeClr val="accent1">
+                <a:shade val="15000"/>
+              </a:schemeClr>
+            </a:lnRef>
+            <a:fillRef idx="1">
+              <a:schemeClr val="accent1"/>
+            </a:fillRef>
+            <a:effectRef idx="0">
+              <a:schemeClr val="accent1"/>
+            </a:effectRef>
+            <a:fontRef idx="minor">
+              <a:schemeClr val="lt1"/>
+            </a:fontRef>
+          </p:style>
+          <p:txBody>
+            <a:bodyPr rtlCol="0" anchor="ctr"/>
+            <a:lstStyle>
+              <a:defPPr>
+                <a:defRPr lang="en-US"/>
+              </a:defPPr>
+              <a:lvl1pPr algn="ctr">
+                <a:defRPr b="1">
+                  <a:solidFill>
+                    <a:schemeClr val="lt1"/>
+                  </a:solidFill>
+                </a:defRPr>
+              </a:lvl1pPr>
+              <a:lvl2pPr>
+                <a:defRPr>
+                  <a:solidFill>
+                    <a:schemeClr val="lt1"/>
+                  </a:solidFill>
+                </a:defRPr>
+              </a:lvl2pPr>
+              <a:lvl3pPr>
+                <a:defRPr>
+                  <a:solidFill>
+                    <a:schemeClr val="lt1"/>
+                  </a:solidFill>
+                </a:defRPr>
+              </a:lvl3pPr>
+              <a:lvl4pPr>
+                <a:defRPr>
+                  <a:solidFill>
+                    <a:schemeClr val="lt1"/>
+                  </a:solidFill>
+                </a:defRPr>
+              </a:lvl4pPr>
+              <a:lvl5pPr>
+                <a:defRPr>
+                  <a:solidFill>
+                    <a:schemeClr val="lt1"/>
+                  </a:solidFill>
+                </a:defRPr>
+              </a:lvl5pPr>
+              <a:lvl6pPr>
+                <a:defRPr>
+                  <a:solidFill>
+                    <a:schemeClr val="lt1"/>
+                  </a:solidFill>
+                </a:defRPr>
+              </a:lvl6pPr>
+              <a:lvl7pPr>
+                <a:defRPr>
+                  <a:solidFill>
+                    <a:schemeClr val="lt1"/>
+                  </a:solidFill>
+                </a:defRPr>
+              </a:lvl7pPr>
+              <a:lvl8pPr>
+                <a:defRPr>
+                  <a:solidFill>
+                    <a:schemeClr val="lt1"/>
+                  </a:solidFill>
+                </a:defRPr>
+              </a:lvl8pPr>
+              <a:lvl9pPr>
+                <a:defRPr>
+                  <a:solidFill>
+                    <a:schemeClr val="lt1"/>
+                  </a:solidFill>
+                </a:defRPr>
+              </a:lvl9pPr>
+            </a:lstStyle>
+            <a:p>
+              <a:r>
+                <a:rPr lang="en-US" dirty="0">
+                  <a:solidFill>
+                    <a:schemeClr val="tx2">
+                      <a:lumMod val="75000"/>
+                      <a:lumOff val="25000"/>
+                    </a:schemeClr>
+                  </a:solidFill>
+                </a:rPr>
+                <a:t>Owner</a:t>
+              </a:r>
+            </a:p>
+          </p:txBody>
+        </p:sp>
+        <p:sp>
+          <p:nvSpPr>
+            <p:cNvPr id="4" name="TextBox 3">
+              <a:extLst>
+                <a:ext uri="{FF2B5EF4-FFF2-40B4-BE49-F238E27FC236}">
+                  <a16:creationId xmlns:a16="http://schemas.microsoft.com/office/drawing/2014/main" id="{39230479-BA94-FE5A-F6EB-60E1FA9214DE}"/>
+                </a:ext>
+              </a:extLst>
+            </p:cNvPr>
+            <p:cNvSpPr txBox="1"/>
+            <p:nvPr/>
+          </p:nvSpPr>
+          <p:spPr>
+            <a:xfrm>
+              <a:off x="11349050" y="754485"/>
+              <a:ext cx="960580" cy="448123"/>
+            </a:xfrm>
+            <a:prstGeom prst="rect">
+              <a:avLst/>
+            </a:prstGeom>
+            <a:solidFill>
+              <a:schemeClr val="accent1">
+                <a:lumMod val="20000"/>
+                <a:lumOff val="80000"/>
+              </a:schemeClr>
+            </a:solidFill>
+            <a:ln>
+              <a:solidFill>
+                <a:schemeClr val="tx2">
+                  <a:lumMod val="10000"/>
+                  <a:lumOff val="90000"/>
+                </a:schemeClr>
+              </a:solidFill>
+            </a:ln>
+          </p:spPr>
+          <p:style>
+            <a:lnRef idx="2">
+              <a:schemeClr val="accent1">
+                <a:shade val="15000"/>
+              </a:schemeClr>
+            </a:lnRef>
+            <a:fillRef idx="1">
+              <a:schemeClr val="accent1"/>
+            </a:fillRef>
+            <a:effectRef idx="0">
+              <a:schemeClr val="accent1"/>
+            </a:effectRef>
+            <a:fontRef idx="minor">
+              <a:schemeClr val="lt1"/>
+            </a:fontRef>
+          </p:style>
+          <p:txBody>
+            <a:bodyPr rtlCol="0" anchor="ctr"/>
+            <a:lstStyle>
+              <a:defPPr>
+                <a:defRPr lang="en-US"/>
+              </a:defPPr>
+              <a:lvl1pPr algn="ctr">
+                <a:defRPr b="1">
+                  <a:solidFill>
+                    <a:schemeClr val="lt1"/>
+                  </a:solidFill>
+                </a:defRPr>
+              </a:lvl1pPr>
+              <a:lvl2pPr>
+                <a:defRPr>
+                  <a:solidFill>
+                    <a:schemeClr val="lt1"/>
+                  </a:solidFill>
+                </a:defRPr>
+              </a:lvl2pPr>
+              <a:lvl3pPr>
+                <a:defRPr>
+                  <a:solidFill>
+                    <a:schemeClr val="lt1"/>
+                  </a:solidFill>
+                </a:defRPr>
+              </a:lvl3pPr>
+              <a:lvl4pPr>
+                <a:defRPr>
+                  <a:solidFill>
+                    <a:schemeClr val="lt1"/>
+                  </a:solidFill>
+                </a:defRPr>
+              </a:lvl4pPr>
+              <a:lvl5pPr>
+                <a:defRPr>
+                  <a:solidFill>
+                    <a:schemeClr val="lt1"/>
+                  </a:solidFill>
+                </a:defRPr>
+              </a:lvl5pPr>
+              <a:lvl6pPr>
+                <a:defRPr>
+                  <a:solidFill>
+                    <a:schemeClr val="lt1"/>
+                  </a:solidFill>
+                </a:defRPr>
+              </a:lvl6pPr>
+              <a:lvl7pPr>
+                <a:defRPr>
+                  <a:solidFill>
+                    <a:schemeClr val="lt1"/>
+                  </a:solidFill>
+                </a:defRPr>
+              </a:lvl7pPr>
+              <a:lvl8pPr>
+                <a:defRPr>
+                  <a:solidFill>
+                    <a:schemeClr val="lt1"/>
+                  </a:solidFill>
+                </a:defRPr>
+              </a:lvl8pPr>
+              <a:lvl9pPr>
+                <a:defRPr>
+                  <a:solidFill>
+                    <a:schemeClr val="lt1"/>
+                  </a:solidFill>
+                </a:defRPr>
+              </a:lvl9pPr>
+            </a:lstStyle>
+            <a:p>
+              <a:r>
+                <a:rPr lang="en-US" dirty="0">
+                  <a:solidFill>
+                    <a:schemeClr val="accent1">
+                      <a:lumMod val="75000"/>
+                    </a:schemeClr>
+                  </a:solidFill>
+                </a:rPr>
+                <a:t>Buyer</a:t>
+              </a:r>
+            </a:p>
+          </p:txBody>
+        </p:sp>
+        <p:sp>
+          <p:nvSpPr>
+            <p:cNvPr id="29" name="Arrow: Left 28">
+              <a:extLst>
+                <a:ext uri="{FF2B5EF4-FFF2-40B4-BE49-F238E27FC236}">
+                  <a16:creationId xmlns:a16="http://schemas.microsoft.com/office/drawing/2014/main" id="{9595C5B9-DA02-A25C-BF54-44B01485E83D}"/>
+                </a:ext>
+              </a:extLst>
+            </p:cNvPr>
+            <p:cNvSpPr/>
+            <p:nvPr/>
+          </p:nvSpPr>
+          <p:spPr>
+            <a:xfrm>
+              <a:off x="6372433" y="2700921"/>
+              <a:ext cx="4203267" cy="358048"/>
+            </a:xfrm>
+            <a:prstGeom prst="leftArrow">
+              <a:avLst>
+                <a:gd name="adj1" fmla="val 25757"/>
+                <a:gd name="adj2" fmla="val 50000"/>
+              </a:avLst>
+            </a:prstGeom>
+            <a:solidFill>
+              <a:schemeClr val="accent1">
+                <a:lumMod val="40000"/>
+                <a:lumOff val="60000"/>
+              </a:schemeClr>
+            </a:solidFill>
+            <a:ln>
+              <a:solidFill>
+                <a:schemeClr val="tx2">
+                  <a:lumMod val="50000"/>
+                  <a:lumOff val="50000"/>
+                </a:schemeClr>
+              </a:solidFill>
+            </a:ln>
+          </p:spPr>
+          <p:style>
+            <a:lnRef idx="2">
+              <a:schemeClr val="accent1">
+                <a:shade val="15000"/>
+              </a:schemeClr>
+            </a:lnRef>
+            <a:fillRef idx="1">
+              <a:schemeClr val="accent1"/>
+            </a:fillRef>
+            <a:effectRef idx="0">
+              <a:schemeClr val="accent1"/>
+            </a:effectRef>
+            <a:fontRef idx="minor">
+              <a:schemeClr val="lt1"/>
+            </a:fontRef>
+          </p:style>
+          <p:txBody>
+            <a:bodyPr rtlCol="0" anchor="ctr"/>
+            <a:lstStyle/>
+            <a:p>
+              <a:pPr algn="ctr"/>
+              <a:endParaRPr lang="en-US"/>
+            </a:p>
+          </p:txBody>
+        </p:sp>
+        <p:sp>
+          <p:nvSpPr>
+            <p:cNvPr id="30" name="Arrow: U-Turn 29">
+              <a:extLst>
+                <a:ext uri="{FF2B5EF4-FFF2-40B4-BE49-F238E27FC236}">
+                  <a16:creationId xmlns:a16="http://schemas.microsoft.com/office/drawing/2014/main" id="{9571C847-6A9F-5320-8D2F-4ED62E59D238}"/>
+                </a:ext>
+              </a:extLst>
+            </p:cNvPr>
+            <p:cNvSpPr/>
+            <p:nvPr/>
+          </p:nvSpPr>
+          <p:spPr>
+            <a:xfrm rot="5400000" flipV="1">
+              <a:off x="346095" y="2881239"/>
+              <a:ext cx="1050584" cy="877080"/>
+            </a:xfrm>
+            <a:prstGeom prst="uturnArrow">
+              <a:avLst>
+                <a:gd name="adj1" fmla="val 13910"/>
+                <a:gd name="adj2" fmla="val 25000"/>
+                <a:gd name="adj3" fmla="val 28327"/>
+                <a:gd name="adj4" fmla="val 43750"/>
+                <a:gd name="adj5" fmla="val 75000"/>
+              </a:avLst>
+            </a:prstGeom>
+            <a:solidFill>
+              <a:schemeClr val="accent1">
+                <a:lumMod val="40000"/>
+                <a:lumOff val="60000"/>
+              </a:schemeClr>
+            </a:solidFill>
+            <a:ln>
+              <a:solidFill>
+                <a:schemeClr val="tx2">
+                  <a:lumMod val="50000"/>
+                  <a:lumOff val="50000"/>
+                </a:schemeClr>
+              </a:solidFill>
+            </a:ln>
+          </p:spPr>
+          <p:style>
+            <a:lnRef idx="2">
+              <a:schemeClr val="accent1">
+                <a:shade val="15000"/>
+              </a:schemeClr>
+            </a:lnRef>
+            <a:fillRef idx="1">
+              <a:schemeClr val="accent1"/>
+            </a:fillRef>
+            <a:effectRef idx="0">
+              <a:schemeClr val="accent1"/>
+            </a:effectRef>
+            <a:fontRef idx="minor">
+              <a:schemeClr val="lt1"/>
+            </a:fontRef>
+          </p:style>
+          <p:txBody>
+            <a:bodyPr rtlCol="0" anchor="ctr"/>
+            <a:lstStyle/>
+            <a:p>
+              <a:pPr algn="ctr"/>
+              <a:endParaRPr lang="en-US">
+                <a:solidFill>
+                  <a:schemeClr val="tx1"/>
+                </a:solidFill>
+              </a:endParaRPr>
+            </a:p>
+          </p:txBody>
+        </p:sp>
+        <p:sp>
+          <p:nvSpPr>
+            <p:cNvPr id="31" name="Arrow: Left 30">
+              <a:extLst>
+                <a:ext uri="{FF2B5EF4-FFF2-40B4-BE49-F238E27FC236}">
+                  <a16:creationId xmlns:a16="http://schemas.microsoft.com/office/drawing/2014/main" id="{29567AA4-A29E-9579-076A-86776C6B9C03}"/>
+                </a:ext>
+              </a:extLst>
+            </p:cNvPr>
+            <p:cNvSpPr/>
+            <p:nvPr/>
+          </p:nvSpPr>
+          <p:spPr>
+            <a:xfrm>
+              <a:off x="1401702" y="2657947"/>
+              <a:ext cx="4643338" cy="378425"/>
+            </a:xfrm>
+            <a:prstGeom prst="leftArrow">
+              <a:avLst>
+                <a:gd name="adj1" fmla="val 25757"/>
+                <a:gd name="adj2" fmla="val 50000"/>
+              </a:avLst>
+            </a:prstGeom>
+            <a:solidFill>
+              <a:schemeClr val="accent1">
+                <a:lumMod val="40000"/>
+                <a:lumOff val="60000"/>
+              </a:schemeClr>
+            </a:solidFill>
+            <a:ln>
+              <a:solidFill>
+                <a:schemeClr val="tx2">
+                  <a:lumMod val="50000"/>
+                  <a:lumOff val="50000"/>
+                </a:schemeClr>
+              </a:solidFill>
+            </a:ln>
+          </p:spPr>
+          <p:style>
+            <a:lnRef idx="2">
+              <a:schemeClr val="accent1">
+                <a:shade val="15000"/>
+              </a:schemeClr>
+            </a:lnRef>
+            <a:fillRef idx="1">
+              <a:schemeClr val="accent1"/>
+            </a:fillRef>
+            <a:effectRef idx="0">
+              <a:schemeClr val="accent1"/>
+            </a:effectRef>
+            <a:fontRef idx="minor">
+              <a:schemeClr val="lt1"/>
+            </a:fontRef>
+          </p:style>
+          <p:txBody>
+            <a:bodyPr rtlCol="0" anchor="ctr"/>
+            <a:lstStyle/>
+            <a:p>
+              <a:pPr algn="ctr"/>
+              <a:endParaRPr lang="en-US"/>
+            </a:p>
+          </p:txBody>
+        </p:sp>
+        <p:sp>
+          <p:nvSpPr>
+            <p:cNvPr id="32" name="Arrow: Right 31">
+              <a:extLst>
+                <a:ext uri="{FF2B5EF4-FFF2-40B4-BE49-F238E27FC236}">
+                  <a16:creationId xmlns:a16="http://schemas.microsoft.com/office/drawing/2014/main" id="{8DF8BF0F-E8D4-DCF1-CF57-6CB05501BE93}"/>
+                </a:ext>
+              </a:extLst>
+            </p:cNvPr>
+            <p:cNvSpPr/>
+            <p:nvPr/>
+          </p:nvSpPr>
+          <p:spPr>
+            <a:xfrm>
+              <a:off x="3818084" y="3479674"/>
+              <a:ext cx="787502" cy="865761"/>
+            </a:xfrm>
+            <a:prstGeom prst="rightArrow">
+              <a:avLst/>
+            </a:prstGeom>
+            <a:solidFill>
+              <a:schemeClr val="accent1">
+                <a:lumMod val="40000"/>
+                <a:lumOff val="60000"/>
+              </a:schemeClr>
+            </a:solidFill>
+            <a:ln>
+              <a:solidFill>
+                <a:schemeClr val="tx2">
+                  <a:lumMod val="50000"/>
+                  <a:lumOff val="50000"/>
+                </a:schemeClr>
+              </a:solidFill>
+            </a:ln>
+          </p:spPr>
+          <p:style>
+            <a:lnRef idx="2">
+              <a:schemeClr val="accent1">
+                <a:shade val="15000"/>
+              </a:schemeClr>
+            </a:lnRef>
+            <a:fillRef idx="1">
+              <a:schemeClr val="accent1"/>
+            </a:fillRef>
+            <a:effectRef idx="0">
+              <a:schemeClr val="accent1"/>
+            </a:effectRef>
+            <a:fontRef idx="minor">
+              <a:schemeClr val="lt1"/>
+            </a:fontRef>
+          </p:style>
+          <p:txBody>
+            <a:bodyPr rtlCol="0" anchor="ctr"/>
+            <a:lstStyle/>
+            <a:p>
+              <a:pPr algn="ctr"/>
+              <a:endParaRPr lang="en-US"/>
+            </a:p>
+          </p:txBody>
+        </p:sp>
+        <p:sp>
+          <p:nvSpPr>
+            <p:cNvPr id="33" name="Arrow: Right 32">
+              <a:extLst>
+                <a:ext uri="{FF2B5EF4-FFF2-40B4-BE49-F238E27FC236}">
+                  <a16:creationId xmlns:a16="http://schemas.microsoft.com/office/drawing/2014/main" id="{9D1BF405-5C20-A2ED-7EBF-E7DFBEB5BEF5}"/>
+                </a:ext>
+              </a:extLst>
+            </p:cNvPr>
+            <p:cNvSpPr/>
+            <p:nvPr/>
+          </p:nvSpPr>
+          <p:spPr>
+            <a:xfrm>
+              <a:off x="7388446" y="3479674"/>
+              <a:ext cx="794472" cy="865761"/>
+            </a:xfrm>
+            <a:prstGeom prst="rightArrow">
+              <a:avLst/>
+            </a:prstGeom>
+            <a:solidFill>
+              <a:schemeClr val="accent1">
+                <a:lumMod val="40000"/>
+                <a:lumOff val="60000"/>
+              </a:schemeClr>
+            </a:solidFill>
+            <a:ln>
+              <a:solidFill>
+                <a:schemeClr val="tx2">
+                  <a:lumMod val="50000"/>
+                  <a:lumOff val="50000"/>
+                </a:schemeClr>
+              </a:solidFill>
+            </a:ln>
+          </p:spPr>
+          <p:style>
+            <a:lnRef idx="2">
+              <a:schemeClr val="accent1">
+                <a:shade val="15000"/>
+              </a:schemeClr>
+            </a:lnRef>
+            <a:fillRef idx="1">
+              <a:schemeClr val="accent1"/>
+            </a:fillRef>
+            <a:effectRef idx="0">
+              <a:schemeClr val="accent1"/>
+            </a:effectRef>
+            <a:fontRef idx="minor">
+              <a:schemeClr val="lt1"/>
+            </a:fontRef>
+          </p:style>
+          <p:txBody>
+            <a:bodyPr rtlCol="0" anchor="ctr"/>
+            <a:lstStyle/>
+            <a:p>
+              <a:pPr algn="ctr"/>
+              <a:endParaRPr lang="en-US"/>
+            </a:p>
+          </p:txBody>
+        </p:sp>
+        <p:sp>
+          <p:nvSpPr>
+            <p:cNvPr id="34" name="Arrow: Left 33">
+              <a:extLst>
+                <a:ext uri="{FF2B5EF4-FFF2-40B4-BE49-F238E27FC236}">
+                  <a16:creationId xmlns:a16="http://schemas.microsoft.com/office/drawing/2014/main" id="{FAAF1811-5EF3-A643-11B4-6545BB5E7339}"/>
+                </a:ext>
+              </a:extLst>
+            </p:cNvPr>
+            <p:cNvSpPr/>
+            <p:nvPr/>
+          </p:nvSpPr>
+          <p:spPr>
+            <a:xfrm rot="16200000">
+              <a:off x="9678886" y="4736168"/>
+              <a:ext cx="909965" cy="378426"/>
+            </a:xfrm>
+            <a:prstGeom prst="leftArrow">
+              <a:avLst>
+                <a:gd name="adj1" fmla="val 25757"/>
+                <a:gd name="adj2" fmla="val 50000"/>
+              </a:avLst>
+            </a:prstGeom>
+            <a:solidFill>
+              <a:schemeClr val="tx2">
+                <a:lumMod val="25000"/>
+                <a:lumOff val="75000"/>
+              </a:schemeClr>
+            </a:solidFill>
+            <a:ln>
+              <a:solidFill>
+                <a:schemeClr val="tx2">
+                  <a:lumMod val="50000"/>
+                  <a:lumOff val="50000"/>
+                </a:schemeClr>
+              </a:solidFill>
+            </a:ln>
+          </p:spPr>
+          <p:style>
+            <a:lnRef idx="2">
+              <a:schemeClr val="accent1">
+                <a:shade val="15000"/>
+              </a:schemeClr>
+            </a:lnRef>
+            <a:fillRef idx="1">
+              <a:schemeClr val="accent1"/>
+            </a:fillRef>
+            <a:effectRef idx="0">
+              <a:schemeClr val="accent1"/>
+            </a:effectRef>
+            <a:fontRef idx="minor">
+              <a:schemeClr val="lt1"/>
+            </a:fontRef>
+          </p:style>
+          <p:txBody>
+            <a:bodyPr rtlCol="0" anchor="ctr"/>
+            <a:lstStyle/>
+            <a:p>
+              <a:pPr algn="ctr"/>
+              <a:endParaRPr lang="en-US"/>
+            </a:p>
+          </p:txBody>
+        </p:sp>
+        <p:sp>
+          <p:nvSpPr>
+            <p:cNvPr id="35" name="Arrow: Left 34">
+              <a:extLst>
+                <a:ext uri="{FF2B5EF4-FFF2-40B4-BE49-F238E27FC236}">
+                  <a16:creationId xmlns:a16="http://schemas.microsoft.com/office/drawing/2014/main" id="{7520ABAD-1F32-F012-CEC8-E6E460296D8C}"/>
+                </a:ext>
+              </a:extLst>
+            </p:cNvPr>
+            <p:cNvSpPr/>
+            <p:nvPr/>
+          </p:nvSpPr>
+          <p:spPr>
+            <a:xfrm rot="16200000">
+              <a:off x="10277218" y="4736168"/>
+              <a:ext cx="909965" cy="378426"/>
+            </a:xfrm>
+            <a:prstGeom prst="leftArrow">
+              <a:avLst>
+                <a:gd name="adj1" fmla="val 25757"/>
+                <a:gd name="adj2" fmla="val 50000"/>
+              </a:avLst>
+            </a:prstGeom>
+            <a:solidFill>
+              <a:schemeClr val="accent1">
+                <a:lumMod val="40000"/>
+                <a:lumOff val="60000"/>
+              </a:schemeClr>
+            </a:solidFill>
+            <a:ln>
+              <a:solidFill>
+                <a:schemeClr val="tx2">
+                  <a:lumMod val="50000"/>
+                  <a:lumOff val="50000"/>
+                </a:schemeClr>
+              </a:solidFill>
+            </a:ln>
+          </p:spPr>
+          <p:style>
+            <a:lnRef idx="2">
+              <a:schemeClr val="accent1">
+                <a:shade val="15000"/>
+              </a:schemeClr>
+            </a:lnRef>
+            <a:fillRef idx="1">
+              <a:schemeClr val="accent1"/>
+            </a:fillRef>
+            <a:effectRef idx="0">
+              <a:schemeClr val="accent1"/>
+            </a:effectRef>
+            <a:fontRef idx="minor">
+              <a:schemeClr val="lt1"/>
+            </a:fontRef>
+          </p:style>
+          <p:txBody>
+            <a:bodyPr rtlCol="0" anchor="ctr"/>
+            <a:lstStyle/>
+            <a:p>
+              <a:pPr algn="ctr"/>
+              <a:endParaRPr lang="en-US"/>
+            </a:p>
+          </p:txBody>
+        </p:sp>
+        <p:sp>
+          <p:nvSpPr>
+            <p:cNvPr id="36" name="TextBox 35">
+              <a:extLst>
+                <a:ext uri="{FF2B5EF4-FFF2-40B4-BE49-F238E27FC236}">
+                  <a16:creationId xmlns:a16="http://schemas.microsoft.com/office/drawing/2014/main" id="{93792F65-72B6-5544-098C-50C1AAC6C501}"/>
+                </a:ext>
+              </a:extLst>
+            </p:cNvPr>
+            <p:cNvSpPr txBox="1"/>
+            <p:nvPr/>
+          </p:nvSpPr>
+          <p:spPr>
+            <a:xfrm>
+              <a:off x="9487785" y="5380364"/>
+              <a:ext cx="960580" cy="909966"/>
+            </a:xfrm>
+            <a:prstGeom prst="rect">
+              <a:avLst/>
+            </a:prstGeom>
+            <a:solidFill>
+              <a:schemeClr val="tx2">
+                <a:lumMod val="10000"/>
+                <a:lumOff val="90000"/>
+              </a:schemeClr>
+            </a:solidFill>
+            <a:ln>
+              <a:solidFill>
+                <a:schemeClr val="tx2">
+                  <a:lumMod val="10000"/>
+                  <a:lumOff val="90000"/>
+                </a:schemeClr>
+              </a:solidFill>
+            </a:ln>
+          </p:spPr>
+          <p:style>
+            <a:lnRef idx="2">
+              <a:schemeClr val="accent1">
+                <a:shade val="15000"/>
+              </a:schemeClr>
+            </a:lnRef>
+            <a:fillRef idx="1">
+              <a:schemeClr val="accent1"/>
+            </a:fillRef>
+            <a:effectRef idx="0">
+              <a:schemeClr val="accent1"/>
+            </a:effectRef>
+            <a:fontRef idx="minor">
+              <a:schemeClr val="lt1"/>
+            </a:fontRef>
+          </p:style>
+          <p:txBody>
+            <a:bodyPr rtlCol="0" anchor="ctr"/>
+            <a:lstStyle>
+              <a:defPPr>
+                <a:defRPr lang="en-US"/>
+              </a:defPPr>
+              <a:lvl1pPr algn="ctr">
+                <a:defRPr b="1">
+                  <a:solidFill>
+                    <a:schemeClr val="lt1"/>
+                  </a:solidFill>
+                </a:defRPr>
+              </a:lvl1pPr>
+              <a:lvl2pPr>
+                <a:defRPr>
+                  <a:solidFill>
+                    <a:schemeClr val="lt1"/>
+                  </a:solidFill>
+                </a:defRPr>
+              </a:lvl2pPr>
+              <a:lvl3pPr>
+                <a:defRPr>
+                  <a:solidFill>
+                    <a:schemeClr val="lt1"/>
+                  </a:solidFill>
+                </a:defRPr>
+              </a:lvl3pPr>
+              <a:lvl4pPr>
+                <a:defRPr>
+                  <a:solidFill>
+                    <a:schemeClr val="lt1"/>
+                  </a:solidFill>
+                </a:defRPr>
+              </a:lvl4pPr>
+              <a:lvl5pPr>
+                <a:defRPr>
+                  <a:solidFill>
+                    <a:schemeClr val="lt1"/>
+                  </a:solidFill>
+                </a:defRPr>
+              </a:lvl5pPr>
+              <a:lvl6pPr>
+                <a:defRPr>
+                  <a:solidFill>
+                    <a:schemeClr val="lt1"/>
+                  </a:solidFill>
+                </a:defRPr>
+              </a:lvl6pPr>
+              <a:lvl7pPr>
+                <a:defRPr>
+                  <a:solidFill>
+                    <a:schemeClr val="lt1"/>
+                  </a:solidFill>
+                </a:defRPr>
+              </a:lvl7pPr>
+              <a:lvl8pPr>
+                <a:defRPr>
+                  <a:solidFill>
+                    <a:schemeClr val="lt1"/>
+                  </a:solidFill>
+                </a:defRPr>
+              </a:lvl8pPr>
+              <a:lvl9pPr>
+                <a:defRPr>
+                  <a:solidFill>
+                    <a:schemeClr val="lt1"/>
+                  </a:solidFill>
+                </a:defRPr>
+              </a:lvl9pPr>
+            </a:lstStyle>
+            <a:p>
+              <a:r>
+                <a:rPr lang="en-US" dirty="0">
+                  <a:solidFill>
+                    <a:schemeClr val="tx2">
+                      <a:lumMod val="75000"/>
+                      <a:lumOff val="25000"/>
+                    </a:schemeClr>
+                  </a:solidFill>
+                </a:rPr>
+                <a:t>Owner Risk Report</a:t>
+              </a:r>
+            </a:p>
+          </p:txBody>
+        </p:sp>
+        <p:sp>
+          <p:nvSpPr>
+            <p:cNvPr id="37" name="TextBox 36">
+              <a:extLst>
+                <a:ext uri="{FF2B5EF4-FFF2-40B4-BE49-F238E27FC236}">
+                  <a16:creationId xmlns:a16="http://schemas.microsoft.com/office/drawing/2014/main" id="{E2E8CA04-1C20-B237-B586-CA3B075A7D1D}"/>
+                </a:ext>
+              </a:extLst>
+            </p:cNvPr>
+            <p:cNvSpPr txBox="1"/>
+            <p:nvPr/>
+          </p:nvSpPr>
+          <p:spPr>
+            <a:xfrm>
+              <a:off x="10575700" y="5380364"/>
+              <a:ext cx="960580" cy="909966"/>
+            </a:xfrm>
+            <a:prstGeom prst="rect">
+              <a:avLst/>
+            </a:prstGeom>
+            <a:solidFill>
+              <a:schemeClr val="accent1">
+                <a:lumMod val="20000"/>
+                <a:lumOff val="80000"/>
+              </a:schemeClr>
+            </a:solidFill>
+            <a:ln>
+              <a:solidFill>
+                <a:schemeClr val="tx2">
+                  <a:lumMod val="10000"/>
+                  <a:lumOff val="90000"/>
+                </a:schemeClr>
+              </a:solidFill>
+            </a:ln>
+          </p:spPr>
+          <p:style>
+            <a:lnRef idx="2">
+              <a:schemeClr val="accent1">
+                <a:shade val="15000"/>
+              </a:schemeClr>
+            </a:lnRef>
+            <a:fillRef idx="1">
+              <a:schemeClr val="accent1"/>
+            </a:fillRef>
+            <a:effectRef idx="0">
+              <a:schemeClr val="accent1"/>
+            </a:effectRef>
+            <a:fontRef idx="minor">
+              <a:schemeClr val="lt1"/>
+            </a:fontRef>
+          </p:style>
+          <p:txBody>
+            <a:bodyPr rtlCol="0" anchor="ctr"/>
+            <a:lstStyle>
+              <a:defPPr>
+                <a:defRPr lang="en-US"/>
+              </a:defPPr>
+              <a:lvl1pPr algn="ctr">
+                <a:defRPr b="1">
+                  <a:solidFill>
+                    <a:schemeClr val="lt1"/>
+                  </a:solidFill>
+                </a:defRPr>
+              </a:lvl1pPr>
+              <a:lvl2pPr>
+                <a:defRPr>
+                  <a:solidFill>
+                    <a:schemeClr val="lt1"/>
+                  </a:solidFill>
+                </a:defRPr>
+              </a:lvl2pPr>
+              <a:lvl3pPr>
+                <a:defRPr>
+                  <a:solidFill>
+                    <a:schemeClr val="lt1"/>
+                  </a:solidFill>
+                </a:defRPr>
+              </a:lvl3pPr>
+              <a:lvl4pPr>
+                <a:defRPr>
+                  <a:solidFill>
+                    <a:schemeClr val="lt1"/>
+                  </a:solidFill>
+                </a:defRPr>
+              </a:lvl4pPr>
+              <a:lvl5pPr>
+                <a:defRPr>
+                  <a:solidFill>
+                    <a:schemeClr val="lt1"/>
+                  </a:solidFill>
+                </a:defRPr>
+              </a:lvl5pPr>
+              <a:lvl6pPr>
+                <a:defRPr>
+                  <a:solidFill>
+                    <a:schemeClr val="lt1"/>
+                  </a:solidFill>
+                </a:defRPr>
+              </a:lvl6pPr>
+              <a:lvl7pPr>
+                <a:defRPr>
+                  <a:solidFill>
+                    <a:schemeClr val="lt1"/>
+                  </a:solidFill>
+                </a:defRPr>
+              </a:lvl7pPr>
+              <a:lvl8pPr>
+                <a:defRPr>
+                  <a:solidFill>
+                    <a:schemeClr val="lt1"/>
+                  </a:solidFill>
+                </a:defRPr>
+              </a:lvl8pPr>
+              <a:lvl9pPr>
+                <a:defRPr>
+                  <a:solidFill>
+                    <a:schemeClr val="lt1"/>
+                  </a:solidFill>
+                </a:defRPr>
+              </a:lvl9pPr>
+            </a:lstStyle>
+            <a:p>
+              <a:r>
+                <a:rPr lang="en-US" dirty="0">
+                  <a:solidFill>
+                    <a:schemeClr val="accent1">
+                      <a:lumMod val="75000"/>
+                    </a:schemeClr>
+                  </a:solidFill>
+                </a:rPr>
+                <a:t>Buyer Risk Report</a:t>
+              </a:r>
+            </a:p>
+          </p:txBody>
+        </p:sp>
+      </p:grpSp>
+    </p:spTree>
+    <p:extLst>
+      <p:ext uri="{BB962C8B-B14F-4D97-AF65-F5344CB8AC3E}">
+        <p14:creationId xmlns:p14="http://schemas.microsoft.com/office/powerpoint/2010/main" val="3825794395"/>
+      </p:ext>
+    </p:extLst>
+  </p:cSld>
+  <p:clrMapOvr>
+    <a:masterClrMapping/>
+  </p:clrMapOvr>
+</p:sld>
+</file>
+
 <file path=ppt/theme/theme1.xml><?xml version="1.0" encoding="utf-8"?>
 <a:theme xmlns:a="http://schemas.openxmlformats.org/drawingml/2006/main" name="Office Theme">
   <a:themeElements>

</xml_diff>